<commit_message>
Redraw all talk figures in the NLD figure palette
- figs_slides.py: NLD series colours bound to method; true signals dashed
  in the reference grey; no near-black bars.
- make_slide_figs.py: rebuilds the nine original slide figures from
  bench.py so every curve is reproducible.
- figs_delay.py: delay and causal figures in the same palette.
- Impact figure now uses bench_delay.vibroimpact; README impact table
  updated (16.9 / 21.2 / 22.8 / 24.6 %, same ranking) and the change noted.
- Talk rebuilt with the new figures.

Co-Authored-By: Claude Opus 5.5 <noreply@anthropic.com>
Claude-Session: https://claude.ai/code/session_01UEf7tjhBJPioETTxv6iXFR
</commit_message>
<xml_diff>
--- a/talk/differentiation_integration_talk.pptx
+++ b/talk/differentiation_integration_talk.pptx
@@ -6696,8 +6696,8 @@
         </p:blipFill>
         <p:spPr>
           <a:xfrm>
-            <a:off x="1690957" y="1920240"/>
-            <a:ext cx="8816181" cy="3794760"/>
+            <a:off x="1829942" y="1920240"/>
+            <a:ext cx="8538210" cy="3794760"/>
           </a:xfrm>
           <a:prstGeom prst="rect">
             <a:avLst/>
@@ -6712,8 +6712,8 @@
         </p:nvSpPr>
         <p:spPr>
           <a:xfrm>
-            <a:off x="1690957" y="5824728"/>
-            <a:ext cx="8816181" cy="502920"/>
+            <a:off x="1829942" y="5824728"/>
+            <a:ext cx="8538210" cy="502920"/>
           </a:xfrm>
           <a:prstGeom prst="rect">
             <a:avLst/>
@@ -8197,7 +8197,7 @@
                   <a:srgbClr val="132433"/>
                 </a:solidFill>
               </a:rPr>
-              <a:t>Best method tested at an impact: 19.2% vs 22–27% for every quadratic penalty</a:t>
+              <a:t>Best method tested at an impact: 16.9% vs 21–25% for every quadratic penalty</a:t>
             </a:r>
           </a:p>
           <a:p>
@@ -8620,8 +8620,8 @@
         </p:blipFill>
         <p:spPr>
           <a:xfrm>
-            <a:off x="1690957" y="1920240"/>
-            <a:ext cx="8816181" cy="3794760"/>
+            <a:off x="1829942" y="1920240"/>
+            <a:ext cx="8538210" cy="3794760"/>
           </a:xfrm>
           <a:prstGeom prst="rect">
             <a:avLst/>
@@ -8636,8 +8636,8 @@
         </p:nvSpPr>
         <p:spPr>
           <a:xfrm>
-            <a:off x="1690957" y="5824728"/>
-            <a:ext cx="8816181" cy="502920"/>
+            <a:off x="1829942" y="5824728"/>
+            <a:ext cx="8538210" cy="502920"/>
           </a:xfrm>
           <a:prstGeom prst="rect">
             <a:avLst/>
@@ -9812,8 +9812,8 @@
         </p:blipFill>
         <p:spPr>
           <a:xfrm>
-            <a:off x="1690957" y="1920240"/>
-            <a:ext cx="8816181" cy="3794760"/>
+            <a:off x="1829942" y="1920240"/>
+            <a:ext cx="8538210" cy="3794760"/>
           </a:xfrm>
           <a:prstGeom prst="rect">
             <a:avLst/>
@@ -9828,8 +9828,8 @@
         </p:nvSpPr>
         <p:spPr>
           <a:xfrm>
-            <a:off x="1690957" y="5824728"/>
-            <a:ext cx="8816181" cy="502920"/>
+            <a:off x="1829942" y="5824728"/>
+            <a:ext cx="8538210" cy="502920"/>
           </a:xfrm>
           <a:prstGeom prst="rect">
             <a:avLst/>
@@ -10242,8 +10242,8 @@
         </p:blipFill>
         <p:spPr>
           <a:xfrm>
-            <a:off x="1690957" y="1920240"/>
-            <a:ext cx="8816181" cy="3794760"/>
+            <a:off x="1829942" y="1920240"/>
+            <a:ext cx="8538210" cy="3794760"/>
           </a:xfrm>
           <a:prstGeom prst="rect">
             <a:avLst/>
@@ -10258,8 +10258,8 @@
         </p:nvSpPr>
         <p:spPr>
           <a:xfrm>
-            <a:off x="1690957" y="5824728"/>
-            <a:ext cx="8816181" cy="502920"/>
+            <a:off x="1829942" y="5824728"/>
+            <a:ext cx="8538210" cy="502920"/>
           </a:xfrm>
           <a:prstGeom prst="rect">
             <a:avLst/>
@@ -13912,8 +13912,8 @@
         </p:blipFill>
         <p:spPr>
           <a:xfrm>
-            <a:off x="1690957" y="1920240"/>
-            <a:ext cx="8816181" cy="3794760"/>
+            <a:off x="1829942" y="1920240"/>
+            <a:ext cx="8538210" cy="3794760"/>
           </a:xfrm>
           <a:prstGeom prst="rect">
             <a:avLst/>
@@ -13928,8 +13928,8 @@
         </p:nvSpPr>
         <p:spPr>
           <a:xfrm>
-            <a:off x="1690957" y="5824728"/>
-            <a:ext cx="8816181" cy="502920"/>
+            <a:off x="1829942" y="5824728"/>
+            <a:ext cx="8538210" cy="502920"/>
           </a:xfrm>
           <a:prstGeom prst="rect">
             <a:avLst/>
@@ -14074,8 +14074,8 @@
         </p:blipFill>
         <p:spPr>
           <a:xfrm>
-            <a:off x="1690957" y="1920240"/>
-            <a:ext cx="8816181" cy="3794760"/>
+            <a:off x="1829942" y="1920240"/>
+            <a:ext cx="8538210" cy="3794760"/>
           </a:xfrm>
           <a:prstGeom prst="rect">
             <a:avLst/>
@@ -14090,8 +14090,8 @@
         </p:nvSpPr>
         <p:spPr>
           <a:xfrm>
-            <a:off x="1690957" y="5824728"/>
-            <a:ext cx="8816181" cy="502920"/>
+            <a:off x="1829942" y="5824728"/>
+            <a:ext cx="8538210" cy="502920"/>
           </a:xfrm>
           <a:prstGeom prst="rect">
             <a:avLst/>
@@ -18830,8 +18830,8 @@
         </p:blipFill>
         <p:spPr>
           <a:xfrm>
-            <a:off x="1690957" y="1920240"/>
-            <a:ext cx="8816181" cy="3794760"/>
+            <a:off x="1829942" y="1920240"/>
+            <a:ext cx="8538210" cy="3794760"/>
           </a:xfrm>
           <a:prstGeom prst="rect">
             <a:avLst/>
@@ -18846,8 +18846,8 @@
         </p:nvSpPr>
         <p:spPr>
           <a:xfrm>
-            <a:off x="1690957" y="5824728"/>
-            <a:ext cx="8816181" cy="502920"/>
+            <a:off x="1829942" y="5824728"/>
+            <a:ext cx="8538210" cy="502920"/>
           </a:xfrm>
           <a:prstGeom prst="rect">
             <a:avLst/>
@@ -19036,8 +19036,8 @@
         </p:blipFill>
         <p:spPr>
           <a:xfrm>
-            <a:off x="1690957" y="1920240"/>
-            <a:ext cx="8816181" cy="3794760"/>
+            <a:off x="1829942" y="1920240"/>
+            <a:ext cx="8538210" cy="3794760"/>
           </a:xfrm>
           <a:prstGeom prst="rect">
             <a:avLst/>
@@ -19052,8 +19052,8 @@
         </p:nvSpPr>
         <p:spPr>
           <a:xfrm>
-            <a:off x="1690957" y="5824728"/>
-            <a:ext cx="8816181" cy="502920"/>
+            <a:off x="1829942" y="5824728"/>
+            <a:ext cx="8538210" cy="502920"/>
           </a:xfrm>
           <a:prstGeom prst="rect">
             <a:avLst/>
@@ -20573,8 +20573,8 @@
         </p:blipFill>
         <p:spPr>
           <a:xfrm>
-            <a:off x="1690957" y="1920240"/>
-            <a:ext cx="8816181" cy="3794760"/>
+            <a:off x="1829942" y="1920240"/>
+            <a:ext cx="8538210" cy="3794760"/>
           </a:xfrm>
           <a:prstGeom prst="rect">
             <a:avLst/>
@@ -20589,8 +20589,8 @@
         </p:nvSpPr>
         <p:spPr>
           <a:xfrm>
-            <a:off x="1690957" y="5824728"/>
-            <a:ext cx="8816181" cy="502920"/>
+            <a:off x="1829942" y="5824728"/>
+            <a:ext cx="8538210" cy="502920"/>
           </a:xfrm>
           <a:prstGeom prst="rect">
             <a:avLst/>

</xml_diff>

<commit_message>
Typeset L1/L2 norms with subscripts in the talk and impact figure
Co-Authored-By: Claude Opus 5.5 <noreply@anthropic.com>
Claude-Session: https://claude.ai/code/session_01UEf7tjhBJPioETTxv6iXFR
</commit_message>
<xml_diff>
--- a/talk/differentiation_integration_talk.pptx
+++ b/talk/differentiation_integration_talk.pptx
@@ -5976,7 +5976,31 @@
                   <a:srgbClr val="132433"/>
                 </a:solidFill>
               </a:rPr>
-              <a:t>Noticeably worse than an L2 penalty for second derivatives (2.4% vs 0.9% here)</a:t>
+              <a:t xml:space="preserve">Noticeably worse than an </a:t>
+            </a:r>
+            <a:r>
+              <a:rPr sz="1500" b="0" i="0">
+                <a:solidFill>
+                  <a:srgbClr val="132433"/>
+                </a:solidFill>
+              </a:rPr>
+              <a:t>L</a:t>
+            </a:r>
+            <a:r>
+              <a:rPr sz="1500" b="0" i="0" baseline="-25000">
+                <a:solidFill>
+                  <a:srgbClr val="132433"/>
+                </a:solidFill>
+              </a:rPr>
+              <a:t>2</a:t>
+            </a:r>
+            <a:r>
+              <a:rPr sz="1500" b="0" i="0">
+                <a:solidFill>
+                  <a:srgbClr val="132433"/>
+                </a:solidFill>
+              </a:rPr>
+              <a:t xml:space="preserve"> penalty for second derivatives (2.4% vs 0.9% here)</a:t>
             </a:r>
           </a:p>
           <a:p>
@@ -6508,7 +6532,31 @@
                   <a:srgbClr val="5B6168"/>
                 </a:solidFill>
               </a:rPr>
-              <a:t>Penalise the p-th derivative in L2: min ‖s − x‖² + λ‖Dᵖs‖². One banded solve.</a:t>
+              <a:t xml:space="preserve">Penalise the p-th derivative in </a:t>
+            </a:r>
+            <a:r>
+              <a:rPr sz="1600" b="0" i="1">
+                <a:solidFill>
+                  <a:srgbClr val="5B6168"/>
+                </a:solidFill>
+              </a:rPr>
+              <a:t>L</a:t>
+            </a:r>
+            <a:r>
+              <a:rPr sz="1600" b="0" i="1" baseline="-25000">
+                <a:solidFill>
+                  <a:srgbClr val="5B6168"/>
+                </a:solidFill>
+              </a:rPr>
+              <a:t>2</a:t>
+            </a:r>
+            <a:r>
+              <a:rPr sz="1600" b="0" i="1">
+                <a:solidFill>
+                  <a:srgbClr val="5B6168"/>
+                </a:solidFill>
+              </a:rPr>
+              <a:t>: min ‖s − x‖² + λ‖Dᵖs‖². One banded solve.</a:t>
             </a:r>
           </a:p>
         </p:txBody>
@@ -6870,7 +6918,31 @@
                   <a:srgbClr val="5B6168"/>
                 </a:solidFill>
               </a:rPr>
-              <a:t>Every L2 method has a closed-form map from a corner frequency in Hz to its penalty weight</a:t>
+              <a:t xml:space="preserve">Every </a:t>
+            </a:r>
+            <a:r>
+              <a:rPr sz="1500" b="0" i="1">
+                <a:solidFill>
+                  <a:srgbClr val="5B6168"/>
+                </a:solidFill>
+              </a:rPr>
+              <a:t>L</a:t>
+            </a:r>
+            <a:r>
+              <a:rPr sz="1500" b="0" i="1" baseline="-25000">
+                <a:solidFill>
+                  <a:srgbClr val="5B6168"/>
+                </a:solidFill>
+              </a:rPr>
+              <a:t>2</a:t>
+            </a:r>
+            <a:r>
+              <a:rPr sz="1500" b="0" i="1">
+                <a:solidFill>
+                  <a:srgbClr val="5B6168"/>
+                </a:solidFill>
+              </a:rPr>
+              <a:t xml:space="preserve"> method has a closed-form map from a corner frequency in Hz to its penalty weight</a:t>
             </a:r>
           </a:p>
         </p:txBody>
@@ -8120,7 +8192,17 @@
           <a:lstStyle/>
           <a:p>
             <a:r>
-              <a:t>Total variation (L1)</a:t>
+              <a:t>Total variation (</a:t>
+            </a:r>
+            <a:r>
+              <a:t>L</a:t>
+            </a:r>
+            <a:r>
+              <a:rPr baseline="-25000"/>
+              <a:t>1</a:t>
+            </a:r>
+            <a:r>
+              <a:t>)</a:t>
             </a:r>
           </a:p>
         </p:txBody>
@@ -8294,7 +8376,31 @@
                   <a:srgbClr val="132433"/>
                 </a:solidFill>
               </a:rPr>
-              <a:t>Several times worse than an L2 penalty on smooth signals — 5.1% vs 0.5% here</a:t>
+              <a:t xml:space="preserve">Several times worse than an </a:t>
+            </a:r>
+            <a:r>
+              <a:rPr sz="1500" b="0" i="0">
+                <a:solidFill>
+                  <a:srgbClr val="132433"/>
+                </a:solidFill>
+              </a:rPr>
+              <a:t>L</a:t>
+            </a:r>
+            <a:r>
+              <a:rPr sz="1500" b="0" i="0" baseline="-25000">
+                <a:solidFill>
+                  <a:srgbClr val="132433"/>
+                </a:solidFill>
+              </a:rPr>
+              <a:t>2</a:t>
+            </a:r>
+            <a:r>
+              <a:rPr sz="1500" b="0" i="0">
+                <a:solidFill>
+                  <a:srgbClr val="132433"/>
+                </a:solidFill>
+              </a:rPr>
+              <a:t xml:space="preserve"> penalty on smooth signals — 5.1% vs 0.5% here</a:t>
             </a:r>
           </a:p>
           <a:p>
@@ -8432,7 +8538,31 @@
                   <a:srgbClr val="5B6168"/>
                 </a:solidFill>
               </a:rPr>
-              <a:t>Penalise ‖Du‖₁ instead of ‖Du‖₂. The L1 norm does not punish a single large jump.</a:t>
+              <a:t xml:space="preserve">Penalise ‖Du‖₁ instead of ‖Du‖₂. The </a:t>
+            </a:r>
+            <a:r>
+              <a:rPr sz="1600" b="0" i="1">
+                <a:solidFill>
+                  <a:srgbClr val="5B6168"/>
+                </a:solidFill>
+              </a:rPr>
+              <a:t>L</a:t>
+            </a:r>
+            <a:r>
+              <a:rPr sz="1600" b="0" i="1" baseline="-25000">
+                <a:solidFill>
+                  <a:srgbClr val="5B6168"/>
+                </a:solidFill>
+              </a:rPr>
+              <a:t>1</a:t>
+            </a:r>
+            <a:r>
+              <a:rPr sz="1600" b="0" i="1">
+                <a:solidFill>
+                  <a:srgbClr val="5B6168"/>
+                </a:solidFill>
+              </a:rPr>
+              <a:t xml:space="preserve"> norm does not punish a single large jump.</a:t>
             </a:r>
           </a:p>
         </p:txBody>
@@ -8554,7 +8684,17 @@
           <a:lstStyle/>
           <a:p>
             <a:r>
-              <a:t>Where the L1 penalty earns its place</a:t>
+              <a:t xml:space="preserve">Where the </a:t>
+            </a:r>
+            <a:r>
+              <a:t>L</a:t>
+            </a:r>
+            <a:r>
+              <a:rPr baseline="-25000"/>
+              <a:t>1</a:t>
+            </a:r>
+            <a:r>
+              <a:t xml:space="preserve"> penalty earns its place</a:t>
             </a:r>
           </a:p>
         </p:txBody>
@@ -8793,7 +8933,31 @@
                   <a:srgbClr val="132433"/>
                 </a:solidFill>
               </a:rPr>
-              <a:t>Conjugate gradients stalls at any iteration cap. IRLS on the smoothed L1 stalls too — measured rate 0.997 per iteration.</a:t>
+              <a:t xml:space="preserve">Conjugate gradients stalls at any iteration cap. IRLS on the smoothed </a:t>
+            </a:r>
+            <a:r>
+              <a:rPr sz="1600" b="0" i="0">
+                <a:solidFill>
+                  <a:srgbClr val="132433"/>
+                </a:solidFill>
+              </a:rPr>
+              <a:t>L</a:t>
+            </a:r>
+            <a:r>
+              <a:rPr sz="1600" b="0" i="0" baseline="-25000">
+                <a:solidFill>
+                  <a:srgbClr val="132433"/>
+                </a:solidFill>
+              </a:rPr>
+              <a:t>1</a:t>
+            </a:r>
+            <a:r>
+              <a:rPr sz="1600" b="0" i="0">
+                <a:solidFill>
+                  <a:srgbClr val="132433"/>
+                </a:solidFill>
+              </a:rPr>
+              <a:t xml:space="preserve"> stalls too — measured rate 0.997 per iteration.</a:t>
             </a:r>
           </a:p>
           <a:p>
@@ -8919,7 +9083,31 @@
                   <a:srgbClr val="132433"/>
                 </a:solidFill>
               </a:rPr>
-              <a:t>Fix: substitute w = Au to get L1 trend filtering — the ADMM system is pentadiagonal and constant, so it factors once.</a:t>
+              <a:t xml:space="preserve">Fix: substitute w = Au to get </a:t>
+            </a:r>
+            <a:r>
+              <a:rPr sz="1600" b="0" i="0">
+                <a:solidFill>
+                  <a:srgbClr val="132433"/>
+                </a:solidFill>
+              </a:rPr>
+              <a:t>L</a:t>
+            </a:r>
+            <a:r>
+              <a:rPr sz="1600" b="0" i="0" baseline="-25000">
+                <a:solidFill>
+                  <a:srgbClr val="132433"/>
+                </a:solidFill>
+              </a:rPr>
+              <a:t>1</a:t>
+            </a:r>
+            <a:r>
+              <a:rPr sz="1600" b="0" i="0">
+                <a:solidFill>
+                  <a:srgbClr val="132433"/>
+                </a:solidFill>
+              </a:rPr>
+              <a:t xml:space="preserve"> trend filtering — the ADMM system is pentadiagonal and constant, so it factors once.</a:t>
             </a:r>
           </a:p>
         </p:txBody>
@@ -9506,7 +9694,31 @@
                   <a:srgbClr val="132433"/>
                 </a:solidFill>
               </a:rPr>
-              <a:t>The prior is smoothness — it rounds corners just as the L2 penalties do</a:t>
+              <a:t xml:space="preserve">The prior is smoothness — it rounds corners just as the </a:t>
+            </a:r>
+            <a:r>
+              <a:rPr sz="1300" b="0" i="0">
+                <a:solidFill>
+                  <a:srgbClr val="132433"/>
+                </a:solidFill>
+              </a:rPr>
+              <a:t>L</a:t>
+            </a:r>
+            <a:r>
+              <a:rPr sz="1300" b="0" i="0" baseline="-25000">
+                <a:solidFill>
+                  <a:srgbClr val="132433"/>
+                </a:solidFill>
+              </a:rPr>
+              <a:t>2</a:t>
+            </a:r>
+            <a:r>
+              <a:rPr sz="1300" b="0" i="0">
+                <a:solidFill>
+                  <a:srgbClr val="132433"/>
+                </a:solidFill>
+              </a:rPr>
+              <a:t xml:space="preserve"> penalties do</a:t>
             </a:r>
           </a:p>
           <a:p>
@@ -18039,7 +18251,31 @@
                   <a:srgbClr val="132433"/>
                 </a:solidFill>
               </a:rPr>
-              <a:t>For a genuine corner: an L1 penalty, with the solver's convergence checked.</a:t>
+              <a:t xml:space="preserve">For a genuine corner: an </a:t>
+            </a:r>
+            <a:r>
+              <a:rPr sz="1600" b="0" i="0">
+                <a:solidFill>
+                  <a:srgbClr val="132433"/>
+                </a:solidFill>
+              </a:rPr>
+              <a:t>L</a:t>
+            </a:r>
+            <a:r>
+              <a:rPr sz="1600" b="0" i="0" baseline="-25000">
+                <a:solidFill>
+                  <a:srgbClr val="132433"/>
+                </a:solidFill>
+              </a:rPr>
+              <a:t>1</a:t>
+            </a:r>
+            <a:r>
+              <a:rPr sz="1600" b="0" i="0">
+                <a:solidFill>
+                  <a:srgbClr val="132433"/>
+                </a:solidFill>
+              </a:rPr>
+              <a:t xml:space="preserve"> penalty, with the solver's convergence checked.</a:t>
             </a:r>
           </a:p>
           <a:p>
@@ -18559,7 +18795,31 @@
                   <a:srgbClr val="132433"/>
                 </a:solidFill>
               </a:rPr>
-              <a:t>Kim, Koh, Boyd &amp; Gorinevsky (2009), l1 trend filtering — SIAM Review 51(2):339</a:t>
+              <a:t xml:space="preserve">Kim, Koh, Boyd &amp; Gorinevsky (2009), </a:t>
+            </a:r>
+            <a:r>
+              <a:rPr sz="1600" b="0" i="0">
+                <a:solidFill>
+                  <a:srgbClr val="132433"/>
+                </a:solidFill>
+              </a:rPr>
+              <a:t>ℓ</a:t>
+            </a:r>
+            <a:r>
+              <a:rPr sz="1600" b="0" i="0" baseline="-25000">
+                <a:solidFill>
+                  <a:srgbClr val="132433"/>
+                </a:solidFill>
+              </a:rPr>
+              <a:t>1</a:t>
+            </a:r>
+            <a:r>
+              <a:rPr sz="1600" b="0" i="0">
+                <a:solidFill>
+                  <a:srgbClr val="132433"/>
+                </a:solidFill>
+              </a:rPr>
+              <a:t xml:space="preserve"> trend filtering — SIAM Review 51(2):339</a:t>
             </a:r>
           </a:p>
           <a:p>
@@ -19585,7 +19845,23 @@
                             <a:srgbClr val="132433"/>
                           </a:solidFill>
                         </a:rPr>
-                        <a:t>Its p-th derivative is small in L2</a:t>
+                        <a:t xml:space="preserve">Its p-th derivative is small in </a:t>
+                      </a:r>
+                      <a:r>
+                        <a:rPr sz="1400" b="1" i="0">
+                          <a:solidFill>
+                            <a:srgbClr val="132433"/>
+                          </a:solidFill>
+                        </a:rPr>
+                        <a:t>L</a:t>
+                      </a:r>
+                      <a:r>
+                        <a:rPr sz="1400" b="1" i="0" baseline="-25000">
+                          <a:solidFill>
+                            <a:srgbClr val="132433"/>
+                          </a:solidFill>
+                        </a:rPr>
+                        <a:t>2</a:t>
                       </a:r>
                     </a:p>
                   </a:txBody>
@@ -19669,7 +19945,31 @@
                             <a:srgbClr val="132433"/>
                           </a:solidFill>
                         </a:rPr>
-                        <a:t>Its derivative is piecewise constant (L1)</a:t>
+                        <a:t>Its derivative is piecewise constant (</a:t>
+                      </a:r>
+                      <a:r>
+                        <a:rPr sz="1400" b="1" i="0">
+                          <a:solidFill>
+                            <a:srgbClr val="132433"/>
+                          </a:solidFill>
+                        </a:rPr>
+                        <a:t>L</a:t>
+                      </a:r>
+                      <a:r>
+                        <a:rPr sz="1400" b="1" i="0" baseline="-25000">
+                          <a:solidFill>
+                            <a:srgbClr val="132433"/>
+                          </a:solidFill>
+                        </a:rPr>
+                        <a:t>1</a:t>
+                      </a:r>
+                      <a:r>
+                        <a:rPr sz="1400" b="1" i="0">
+                          <a:solidFill>
+                            <a:srgbClr val="132433"/>
+                          </a:solidFill>
+                        </a:rPr>
+                        <a:t>)</a:t>
                       </a:r>
                     </a:p>
                   </a:txBody>

</xml_diff>